<commit_message>
docs(presentation): sync internship report & slide deck with implemented portal architecture
</commit_message>
<xml_diff>
--- a/presentation/Presentasi_Magang_CSIRT_DKI_Jakarta.pptx
+++ b/presentation/Presentasi_Magang_CSIRT_DKI_Jakarta.pptx
@@ -4153,7 +4153,7 @@
                 </a:solidFill>
                 <a:latin typeface="Inter"/>
               </a:rPr>
-              <a:t>Wizard 3 langkah mengalahkan form flat — pengguna menyerah pada halaman panjang</a:t>
+              <a:t>Form terstruktur &amp; berpanduan mengalahkan form rumit — pengguna awam butuh kejelasan</a:t>
             </a:r>
           </a:p>
           <a:p>
@@ -5522,7 +5522,7 @@
                 </a:solidFill>
                 <a:latin typeface="Inter"/>
               </a:rPr>
-              <a:t>Demo: screenshot portal — menyusul saat live di Render</a:t>
+              <a:t>Demo: live demo melalui Cloudflare Tunnel / secure HTTPS</a:t>
             </a:r>
           </a:p>
         </p:txBody>
@@ -9084,7 +9084,7 @@
                 </a:solidFill>
                 <a:latin typeface="Inter"/>
               </a:rPr>
-              <a:t>Wizard 3 langkah + penanganan error + rate limit</a:t>
+              <a:t>Form insiden terstruktur + proteksi TaC + rate limit</a:t>
             </a:r>
           </a:p>
         </p:txBody>
@@ -9818,7 +9818,7 @@
                 </a:solidFill>
                 <a:latin typeface="Inter"/>
               </a:rPr>
-              <a:t>Form laporan 1 halaman panjang, kotak kosong &amp; skor CVSS</a:t>
+              <a:t>Form lama rumit, penuh input teknis kosong &amp; skor CVSS</a:t>
             </a:r>
           </a:p>
           <a:p>
@@ -10102,7 +10102,7 @@
                 </a:solidFill>
                 <a:latin typeface="Inter"/>
               </a:rPr>
-              <a:t>Wizard 3 langkah yang menuntun pengguna</a:t>
+              <a:t>Form terstruktur ringkas + pelacakan status tiket INS</a:t>
             </a:r>
           </a:p>
           <a:p>
@@ -10870,7 +10870,7 @@
                 </a:solidFill>
                 <a:latin typeface="Inter"/>
               </a:rPr>
-              <a:t>Wizard 3 langkah + halaman Terima Kasih</a:t>
+              <a:t>Form terstruktur + pelacakan tiket INS-YYYY</a:t>
             </a:r>
           </a:p>
         </p:txBody>
@@ -12343,7 +12343,7 @@
                 </a:solidFill>
                 <a:latin typeface="Inter"/>
               </a:rPr>
-              <a:t>Wizard 3 langkah yang menuntun pengguna:</a:t>
+              <a:t>Formulir satu halaman yang terstruktur rapi:</a:t>
             </a:r>
           </a:p>
           <a:p>
@@ -12374,7 +12374,7 @@
                 </a:solidFill>
                 <a:latin typeface="Inter"/>
               </a:rPr>
-              <a:t>Langkah 1 — Siapa yang melapor?</a:t>
+              <a:t>Bagian 1 — Data Insiden (kategori, waktu, URL, deskripsi)</a:t>
             </a:r>
           </a:p>
           <a:p>
@@ -12405,7 +12405,7 @@
                 </a:solidFill>
                 <a:latin typeface="Inter"/>
               </a:rPr>
-              <a:t>Langkah 2 — Website apa yang diserang?</a:t>
+              <a:t>Bagian 2 — Bukti Laporan (file maks 5MB atau URL)</a:t>
             </a:r>
           </a:p>
           <a:p>
@@ -12436,7 +12436,7 @@
                 </a:solidFill>
                 <a:latin typeface="Inter"/>
               </a:rPr>
-              <a:t>Langkah 3 — Apa yang terjadi?</a:t>
+              <a:t>Panduan interaktif kategori serangan &amp; proteksi TaC gate</a:t>
             </a:r>
           </a:p>
           <a:p>
@@ -12467,7 +12467,7 @@
                 </a:solidFill>
                 <a:latin typeface="Inter"/>
               </a:rPr>
-              <a:t>Istilah teknis dibuat opsional — melapor cepat &amp; mudah</a:t>
+              <a:t>Tiket resmi INS-YYYY-XXXX &amp; dashboard pelacakan status</a:t>
             </a:r>
           </a:p>
         </p:txBody>

</xml_diff>